<commit_message>
testing files for playwright
</commit_message>
<xml_diff>
--- a/Milestone 5/Milestone5_Testing&Evaluation.pptx
+++ b/Milestone 5/Milestone5_Testing&Evaluation.pptx
@@ -1595,7 +1595,7 @@
               </a:spcAft>
               <a:buNone/>
             </a:pPr>
-            <a:endParaRPr/>
+            <a:endParaRPr dirty="0"/>
           </a:p>
         </p:txBody>
       </p:sp>
@@ -17090,8 +17090,12 @@
               <a:buChar char="•"/>
             </a:pPr>
             <a:r>
+              <a:rPr lang="en-US" dirty="0" smtClean="0"/>
+              <a:t>Upload video of performing </a:t>
+            </a:r>
+            <a:r>
               <a:rPr lang="en-US" dirty="0"/>
-              <a:t>Record actors performing scenes naturally.</a:t>
+              <a:t>scenes naturally.</a:t>
             </a:r>
           </a:p>
           <a:p>
@@ -17141,7 +17145,15 @@
             </a:pPr>
             <a:r>
               <a:rPr lang="en-US" dirty="0"/>
-              <a:t>Observations – Interviews - Video recordings - User feedback</a:t>
+              <a:t>Observations – Interviews - Video recordings </a:t>
+            </a:r>
+            <a:r>
+              <a:rPr lang="en-US" dirty="0" smtClean="0"/>
+              <a:t>upload- </a:t>
+            </a:r>
+            <a:r>
+              <a:rPr lang="en-US" dirty="0"/>
+              <a:t>User feedback</a:t>
             </a:r>
           </a:p>
         </p:txBody>
@@ -17179,9 +17191,18 @@
               <a:buChar char="•"/>
             </a:pPr>
             <a:r>
-              <a:rPr lang="en-US" dirty="0"/>
-              <a:t>Lighting affects emotion detection</a:t>
+              <a:rPr lang="en-US" dirty="0" smtClean="0"/>
+              <a:t>Backend processing </a:t>
             </a:r>
+            <a:r>
+              <a:rPr lang="en-US" smtClean="0"/>
+              <a:t>time, report </a:t>
+            </a:r>
+            <a:r>
+              <a:rPr lang="en-US" dirty="0" smtClean="0"/>
+              <a:t>accuracy</a:t>
+            </a:r>
+            <a:endParaRPr lang="en-US" dirty="0"/>
           </a:p>
           <a:p>
             <a:pPr marL="285750" lvl="0" indent="-285750" algn="l">
@@ -26636,7 +26657,7 @@
           <p:nvPr>
             <p:extLst>
               <p:ext uri="{D42A27DB-BD31-4B8C-83A1-F6EECF244321}">
-                <p14:modId xmlns:p14="http://schemas.microsoft.com/office/powerpoint/2010/main" val="666758693"/>
+                <p14:modId xmlns:p14="http://schemas.microsoft.com/office/powerpoint/2010/main" val="2591724647"/>
               </p:ext>
             </p:extLst>
           </p:nvPr>
@@ -27472,7 +27493,19 @@
                           <a:cs typeface="Montserrat Medium"/>
                           <a:sym typeface="Montserrat Medium"/>
                         </a:rPr>
-                        <a:t>&lt; 200 </a:t>
+                        <a:t>&lt; </a:t>
+                      </a:r>
+                      <a:r>
+                        <a:rPr lang="en-US" sz="1200" b="1" dirty="0" smtClean="0">
+                          <a:solidFill>
+                            <a:schemeClr val="tx1"/>
+                          </a:solidFill>
+                          <a:latin typeface="Montserrat Medium"/>
+                          <a:ea typeface="Montserrat Medium"/>
+                          <a:cs typeface="Montserrat Medium"/>
+                          <a:sym typeface="Montserrat Medium"/>
+                        </a:rPr>
+                        <a:t>5000 </a:t>
                       </a:r>
                       <a:r>
                         <a:rPr lang="en-US" sz="1200" b="1" dirty="0" err="1" smtClean="0">

</xml_diff>